<commit_message>
docs(deck): restructure the full deck to sixteen slides and clarify the design
The slide on the eigenvalue calculation is merged into the Senglea
slide, since its role is to support one row of the period table and the
spectrum is the test of that row. The slide on the mouth sensitivity is
folded into the research questions, where it is one of three
accompanying questions. The design slide no longer opposes sweep and
hindcast, since both are planned: the sweep of 96 scenarios addresses
the long wave and the hindcast validates circulation and waves. The
assumptions behind the 160 simulated days and the 17-minute period are
stated, the open questions return to one slide of six, three-dimensional
runs move to October, and the closing slide carries the repository link
and the cover photograph.

The cover is now held in docs/deck_cover.pptx, so that a rebuild of
either deck does not depend on a previous build.
</commit_message>
<xml_diff>
--- a/docs/valletta_model_concept_2026-10-08_short.pptx
+++ b/docs/valletta_model_concept_2026-10-08_short.pptx
@@ -8,7 +8,7 @@
     <p:notesMasterId r:id="rId11"/>
   </p:notesMasterIdLst>
   <p:sldIdLst>
-    <p:sldId id="265" r:id="rId2"/>
+    <p:sldId id="275" r:id="rId2"/>
     <p:sldId id="257" r:id="rId3"/>
     <p:sldId id="258" r:id="rId4"/>
     <p:sldId id="259" r:id="rId5"/>
@@ -145,7 +145,7 @@
     </p:spTree>
     <p:extLst>
       <p:ext uri="{BB962C8B-B14F-4D97-AF65-F5344CB8AC3E}">
-        <p14:creationId xmlns:p14="http://schemas.microsoft.com/office/powerpoint/2010/main" val="2126196696"/>
+        <p14:creationId xmlns:p14="http://schemas.microsoft.com/office/powerpoint/2010/main" val="988184106"/>
       </p:ext>
     </p:extLst>
   </p:cSld>
@@ -322,7 +322,7 @@
     </p:spTree>
     <p:extLst>
       <p:ext uri="{BB962C8B-B14F-4D97-AF65-F5344CB8AC3E}">
-        <p14:creationId xmlns:p14="http://schemas.microsoft.com/office/powerpoint/2010/main" val="1611358565"/>
+        <p14:creationId xmlns:p14="http://schemas.microsoft.com/office/powerpoint/2010/main" val="1419756532"/>
       </p:ext>
     </p:extLst>
   </p:cSld>
@@ -1740,7 +1740,7 @@
     </p:spTree>
     <p:extLst>
       <p:ext uri="{BB962C8B-B14F-4D97-AF65-F5344CB8AC3E}">
-        <p14:creationId xmlns:p14="http://schemas.microsoft.com/office/powerpoint/2010/main" val="3598248991"/>
+        <p14:creationId xmlns:p14="http://schemas.microsoft.com/office/powerpoint/2010/main" val="4273070046"/>
       </p:ext>
     </p:extLst>
   </p:cSld>
@@ -7401,7 +7401,7 @@
                 <a:ea typeface="Calibri" pitchFamily="34" charset="-122"/>
                 <a:cs typeface="Calibri" pitchFamily="34" charset="-120"/>
               </a:rPr>
-              <a:t>Some 16 h for the two-dimensional sweep and of the order of 45 h on 8 processes for the three-dimensional runs, the latter scaled from the Stagnone configuration and uncertain by a factor of two.</a:t>
+              <a:t>Some 8 h for the two-dimensional sweep and of the order of 45 h on 8 processes for the three-dimensional runs, the latter scaled from the Stagnone configuration and uncertain by a factor of two.</a:t>
             </a:r>
             <a:endParaRPr lang="en-US" sz="1150" dirty="0"/>
           </a:p>
@@ -7543,7 +7543,7 @@
                 <a:ea typeface="Calibri" pitchFamily="34" charset="-122"/>
                 <a:cs typeface="Calibri" pitchFamily="34" charset="-120"/>
               </a:rPr>
-              <a:t>ERA5 does not resolve the atmospheric gravity waves associated with the phenomenon, so a hindcast of individual events is not attempted.</a:t>
+              <a:t>ERA5 does not resolve the atmospheric gravity waves associated with the milgħuba, so the long wave is studied by a sweep of 96 idealised disturbances, while circulation and waves are validated by a conventional hindcast.</a:t>
             </a:r>
             <a:endParaRPr lang="en-US" sz="1400" dirty="0"/>
           </a:p>
@@ -7683,7 +7683,7 @@
                 <a:ea typeface="Calibri" pitchFamily="34" charset="-122"/>
                 <a:cs typeface="Calibri" pitchFamily="34" charset="-120"/>
               </a:rPr>
-              <a:t>A moving pressure disturbance is imposed, and its speed, direction, width and duration are varied.</a:t>
+              <a:t>A moving pressure disturbance is imposed in a two-dimensional barotropic run, over 6 speeds, 8 directions and 2 widths.</a:t>
             </a:r>
             <a:endParaRPr lang="en-US" sz="1250" dirty="0"/>
           </a:p>
@@ -11226,9 +11226,77 @@
           <a:chExt cx="0" cy="0"/>
         </a:xfrm>
       </p:grpSpPr>
+      <p:pic>
+        <p:nvPicPr>
+          <p:cNvPr id="22" name="Picture 21">
+            <a:extLst>
+              <a:ext uri="{FF2B5EF4-FFF2-40B4-BE49-F238E27FC236}">
+                <a16:creationId xmlns:a16="http://schemas.microsoft.com/office/drawing/2014/main" id="{5CF043AA-8B3E-0E0E-EE0D-70C3EC073409}"/>
+              </a:ext>
+            </a:extLst>
+          </p:cNvPr>
+          <p:cNvPicPr>
+            <a:picLocks noChangeAspect="1"/>
+          </p:cNvPicPr>
+          <p:nvPr/>
+        </p:nvPicPr>
+        <p:blipFill>
+          <a:blip r:embed="rId3">
+            <a:duotone>
+              <a:prstClr val="black"/>
+              <a:schemeClr val="accent1">
+                <a:tint val="45000"/>
+                <a:satMod val="400000"/>
+              </a:schemeClr>
+            </a:duotone>
+          </a:blip>
+          <a:srcRect t="25333"/>
+          <a:stretch>
+            <a:fillRect/>
+          </a:stretch>
+        </p:blipFill>
+        <p:spPr>
+          <a:xfrm>
+            <a:off x="0" y="0"/>
+            <a:ext cx="12242447" cy="6858000"/>
+          </a:xfrm>
+          <a:prstGeom prst="rect">
+            <a:avLst/>
+          </a:prstGeom>
+        </p:spPr>
+      </p:pic>
       <p:sp>
         <p:nvSpPr>
           <p:cNvPr id="2" name="Shape 0"/>
+          <p:cNvSpPr/>
+          <p:nvPr/>
+        </p:nvSpPr>
+        <p:spPr>
+          <a:xfrm>
+            <a:off x="0" y="0"/>
+            <a:ext cx="12188952" cy="6858000"/>
+          </a:xfrm>
+          <a:prstGeom prst="rect">
+            <a:avLst/>
+          </a:prstGeom>
+          <a:solidFill>
+            <a:srgbClr val="21295C">
+              <a:alpha val="70000"/>
+            </a:srgbClr>
+          </a:solidFill>
+          <a:ln w="12700">
+            <a:solidFill>
+              <a:srgbClr val="21295C">
+                <a:alpha val="0"/>
+              </a:srgbClr>
+            </a:solidFill>
+            <a:prstDash val="solid"/>
+          </a:ln>
+        </p:spPr>
+      </p:sp>
+      <p:sp>
+        <p:nvSpPr>
+          <p:cNvPr id="3" name="Shape 1"/>
           <p:cNvSpPr/>
           <p:nvPr/>
         </p:nvSpPr>
@@ -11250,7 +11318,7 @@
       </p:sp>
       <p:sp>
         <p:nvSpPr>
-          <p:cNvPr id="3" name="Text 1"/>
+          <p:cNvPr id="4" name="Text 2"/>
           <p:cNvSpPr txBox="1"/>
           <p:nvPr/>
         </p:nvSpPr>
@@ -11289,7 +11357,7 @@
       </p:sp>
       <p:sp>
         <p:nvSpPr>
-          <p:cNvPr id="4" name="Text 2"/>
+          <p:cNvPr id="5" name="Text 3"/>
           <p:cNvSpPr txBox="1"/>
           <p:nvPr/>
         </p:nvSpPr>
@@ -11328,7 +11396,7 @@
       </p:sp>
       <p:sp>
         <p:nvSpPr>
-          <p:cNvPr id="5" name="Shape 3"/>
+          <p:cNvPr id="6" name="Shape 4"/>
           <p:cNvSpPr/>
           <p:nvPr/>
         </p:nvSpPr>
@@ -11348,7 +11416,7 @@
       </p:sp>
       <p:sp>
         <p:nvSpPr>
-          <p:cNvPr id="6" name="Text 4"/>
+          <p:cNvPr id="7" name="Text 5"/>
           <p:cNvSpPr txBox="1"/>
           <p:nvPr/>
         </p:nvSpPr>
@@ -11387,7 +11455,7 @@
       </p:sp>
       <p:sp>
         <p:nvSpPr>
-          <p:cNvPr id="7" name="Text 5"/>
+          <p:cNvPr id="8" name="Text 6"/>
           <p:cNvSpPr txBox="1"/>
           <p:nvPr/>
         </p:nvSpPr>
@@ -11415,7 +11483,7 @@
             <a:r>
               <a:rPr lang="en-US" sz="1200" dirty="0">
                 <a:solidFill>
-                  <a:srgbClr val="9FB3D1"/>
+                  <a:srgbClr val="DCE7F5"/>
                 </a:solidFill>
                 <a:latin typeface="Calibri" pitchFamily="34" charset="0"/>
                 <a:ea typeface="Calibri" pitchFamily="34" charset="-122"/>
@@ -11429,7 +11497,7 @@
       </p:sp>
       <p:sp>
         <p:nvSpPr>
-          <p:cNvPr id="8" name="Shape 6"/>
+          <p:cNvPr id="9" name="Shape 7"/>
           <p:cNvSpPr/>
           <p:nvPr/>
         </p:nvSpPr>
@@ -11449,7 +11517,7 @@
       </p:sp>
       <p:sp>
         <p:nvSpPr>
-          <p:cNvPr id="9" name="Text 7"/>
+          <p:cNvPr id="10" name="Text 8"/>
           <p:cNvSpPr txBox="1"/>
           <p:nvPr/>
         </p:nvSpPr>
@@ -11488,7 +11556,7 @@
       </p:sp>
       <p:sp>
         <p:nvSpPr>
-          <p:cNvPr id="10" name="Text 8"/>
+          <p:cNvPr id="11" name="Text 9"/>
           <p:cNvSpPr txBox="1"/>
           <p:nvPr/>
         </p:nvSpPr>
@@ -11516,13 +11584,13 @@
             <a:r>
               <a:rPr lang="en-US" sz="1200" dirty="0">
                 <a:solidFill>
-                  <a:srgbClr val="9FB3D1"/>
+                  <a:srgbClr val="DCE7F5"/>
                 </a:solidFill>
                 <a:latin typeface="Calibri" pitchFamily="34" charset="0"/>
                 <a:ea typeface="Calibri" pitchFamily="34" charset="-122"/>
                 <a:cs typeface="Calibri" pitchFamily="34" charset="-120"/>
               </a:rPr>
-              <a:t>Bathymetry at the heads of Msida and Pietà Creeks, remaining boundary tests, response of the mesh to a broadband impulse.</a:t>
+              <a:t>Bathymetry at the heads of Msida and Pietà Creeks, remaining boundary tests, impulse response of the mesh, first three-dimensional runs.</a:t>
             </a:r>
             <a:endParaRPr lang="en-US" sz="1200" dirty="0"/>
           </a:p>
@@ -11530,7 +11598,7 @@
       </p:sp>
       <p:sp>
         <p:nvSpPr>
-          <p:cNvPr id="11" name="Shape 9"/>
+          <p:cNvPr id="12" name="Shape 10"/>
           <p:cNvSpPr/>
           <p:nvPr/>
         </p:nvSpPr>
@@ -11550,7 +11618,7 @@
       </p:sp>
       <p:sp>
         <p:nvSpPr>
-          <p:cNvPr id="12" name="Text 10"/>
+          <p:cNvPr id="13" name="Text 11"/>
           <p:cNvSpPr txBox="1"/>
           <p:nvPr/>
         </p:nvSpPr>
@@ -11589,7 +11657,7 @@
       </p:sp>
       <p:sp>
         <p:nvSpPr>
-          <p:cNvPr id="13" name="Text 11"/>
+          <p:cNvPr id="14" name="Text 12"/>
           <p:cNvSpPr txBox="1"/>
           <p:nvPr/>
         </p:nvSpPr>
@@ -11617,7 +11685,7 @@
             <a:r>
               <a:rPr lang="en-US" sz="1200" dirty="0">
                 <a:solidFill>
-                  <a:srgbClr val="9FB3D1"/>
+                  <a:srgbClr val="DCE7F5"/>
                 </a:solidFill>
                 <a:latin typeface="Calibri" pitchFamily="34" charset="0"/>
                 <a:ea typeface="Calibri" pitchFamily="34" charset="-122"/>
@@ -11631,7 +11699,7 @@
       </p:sp>
       <p:sp>
         <p:nvSpPr>
-          <p:cNvPr id="14" name="Shape 12"/>
+          <p:cNvPr id="15" name="Shape 13"/>
           <p:cNvSpPr/>
           <p:nvPr/>
         </p:nvSpPr>
@@ -11651,7 +11719,7 @@
       </p:sp>
       <p:sp>
         <p:nvSpPr>
-          <p:cNvPr id="15" name="Text 13"/>
+          <p:cNvPr id="16" name="Text 14"/>
           <p:cNvSpPr txBox="1"/>
           <p:nvPr/>
         </p:nvSpPr>
@@ -11690,7 +11758,7 @@
       </p:sp>
       <p:sp>
         <p:nvSpPr>
-          <p:cNvPr id="16" name="Text 14"/>
+          <p:cNvPr id="17" name="Text 15"/>
           <p:cNvSpPr txBox="1"/>
           <p:nvPr/>
         </p:nvSpPr>
@@ -11718,13 +11786,13 @@
             <a:r>
               <a:rPr lang="en-US" sz="1200" dirty="0">
                 <a:solidFill>
-                  <a:srgbClr val="9FB3D1"/>
+                  <a:srgbClr val="DCE7F5"/>
                 </a:solidFill>
                 <a:latin typeface="Calibri" pitchFamily="34" charset="0"/>
                 <a:ea typeface="Calibri" pitchFamily="34" charset="-122"/>
                 <a:cs typeface="Calibri" pitchFamily="34" charset="-120"/>
               </a:rPr>
-              <a:t>Parametric sweep in two dimensions, first three-dimensional runs.</a:t>
+              <a:t>Sweep of the long wave, barotropic and therefore two-dimensional, and the validation hindcast.</a:t>
             </a:r>
             <a:endParaRPr lang="en-US" sz="1200" dirty="0"/>
           </a:p>
@@ -11732,7 +11800,7 @@
       </p:sp>
       <p:sp>
         <p:nvSpPr>
-          <p:cNvPr id="17" name="Shape 15"/>
+          <p:cNvPr id="18" name="Shape 16"/>
           <p:cNvSpPr/>
           <p:nvPr/>
         </p:nvSpPr>
@@ -11756,7 +11824,7 @@
       </p:sp>
       <p:sp>
         <p:nvSpPr>
-          <p:cNvPr id="18" name="Text 16"/>
+          <p:cNvPr id="19" name="Text 17"/>
           <p:cNvSpPr txBox="1"/>
           <p:nvPr/>
         </p:nvSpPr>
@@ -11795,7 +11863,7 @@
       </p:sp>
       <p:sp>
         <p:nvSpPr>
-          <p:cNvPr id="19" name="Text 17"/>
+          <p:cNvPr id="20" name="Text 18"/>
           <p:cNvSpPr txBox="1"/>
           <p:nvPr/>
         </p:nvSpPr>
@@ -11860,14 +11928,14 @@
       </p:sp>
       <p:sp>
         <p:nvSpPr>
-          <p:cNvPr id="20" name="Text 18"/>
+          <p:cNvPr id="21" name="Text 19"/>
           <p:cNvSpPr txBox="1"/>
           <p:nvPr/>
         </p:nvSpPr>
         <p:spPr>
           <a:xfrm>
             <a:off x="566928" y="6199632"/>
-            <a:ext cx="5852160" cy="274320"/>
+            <a:ext cx="8229600" cy="274320"/>
           </a:xfrm>
           <a:prstGeom prst="rect">
             <a:avLst/>
@@ -11883,17 +11951,35 @@
               <a:buNone/>
             </a:pPr>
             <a:r>
-              <a:rPr lang="en-US" sz="1100" i="1" dirty="0">
+              <a:rPr lang="en-US" sz="1150" i="1" dirty="0">
                 <a:solidFill>
-                  <a:srgbClr val="7F93B3"/>
+                  <a:srgbClr val="CADCFC"/>
                 </a:solidFill>
                 <a:latin typeface="Calibri" pitchFamily="34" charset="0"/>
                 <a:ea typeface="Calibri" pitchFamily="34" charset="-122"/>
                 <a:cs typeface="Calibri" pitchFamily="34" charset="-120"/>
               </a:rPr>
-              <a:t>Documents, figures and the reproducible analysis are in the project repository.</a:t>
+              <a:t>Documents, figures and the reproducible analysis: </a:t>
             </a:r>
-            <a:endParaRPr lang="en-US" sz="1100" dirty="0"/>
+            <a:r>
+              <a:rPr lang="en-US" sz="1150" b="1" u="sng" dirty="0">
+                <a:solidFill>
+                  <a:srgbClr val="FFFFFF"/>
+                </a:solidFill>
+                <a:latin typeface="Calibri" pitchFamily="34" charset="0"/>
+                <a:ea typeface="Calibri" pitchFamily="34" charset="-122"/>
+                <a:cs typeface="Calibri" pitchFamily="34" charset="-120"/>
+                <a:hlinkClick r:id="rId4">
+                  <a:extLst>
+                    <a:ext uri="{A12FA001-AC4F-418D-AE19-62706E023703}">
+                      <ahyp:hlinkClr xmlns:ahyp="http://schemas.microsoft.com/office/drawing/2018/hyperlinkcolor" val="tx"/>
+                    </a:ext>
+                  </a:extLst>
+                </a:hlinkClick>
+              </a:rPr>
+              <a:t>github.com/cicero-martins/MaltaDT</a:t>
+            </a:r>
+            <a:endParaRPr lang="en-US" sz="1150" dirty="0"/>
           </a:p>
         </p:txBody>
       </p:sp>

</xml_diff>